<commit_message>
docs: informe y presentación final de práctica profesional
</commit_message>
<xml_diff>
--- a/BitacorasFirmadasPractica/ExposicionFinal/Resultado/PracticaProfesional_PresentacionFinal_KevinCampos.pptx
+++ b/BitacorasFirmadasPractica/ExposicionFinal/Resultado/PracticaProfesional_PresentacionFinal_KevinCampos.pptx
@@ -4485,13 +4485,139 @@
               </a:lnSpc>
             </a:pPr>
             <a:r>
-              <a:rPr sz="1200" b="0">
+              <a:rPr sz="1200" b="0" dirty="0">
                 <a:solidFill>
                   <a:srgbClr val="CADCFC"/>
                 </a:solidFill>
                 <a:latin typeface="Calibri"/>
               </a:rPr>
-              <a:t>Es la instancia responsable del seguimiento y la evaluación de los proyectos estratégicos de la Universidad.</a:t>
+              <a:t>Es la </a:t>
+            </a:r>
+            <a:r>
+              <a:rPr sz="1200" b="0" dirty="0" err="1">
+                <a:solidFill>
+                  <a:srgbClr val="CADCFC"/>
+                </a:solidFill>
+                <a:latin typeface="Calibri"/>
+              </a:rPr>
+              <a:t>instancia</a:t>
+            </a:r>
+            <a:r>
+              <a:rPr sz="1200" b="0" dirty="0">
+                <a:solidFill>
+                  <a:srgbClr val="CADCFC"/>
+                </a:solidFill>
+                <a:latin typeface="Calibri"/>
+              </a:rPr>
+              <a:t> </a:t>
+            </a:r>
+            <a:r>
+              <a:rPr sz="1200" b="0" dirty="0" err="1">
+                <a:solidFill>
+                  <a:srgbClr val="CADCFC"/>
+                </a:solidFill>
+                <a:latin typeface="Calibri"/>
+              </a:rPr>
+              <a:t>responsable</a:t>
+            </a:r>
+            <a:r>
+              <a:rPr sz="1200" b="0" dirty="0">
+                <a:solidFill>
+                  <a:srgbClr val="CADCFC"/>
+                </a:solidFill>
+                <a:latin typeface="Calibri"/>
+              </a:rPr>
+              <a:t> del </a:t>
+            </a:r>
+            <a:r>
+              <a:rPr sz="1200" b="0" dirty="0" err="1">
+                <a:solidFill>
+                  <a:srgbClr val="CADCFC"/>
+                </a:solidFill>
+                <a:latin typeface="Calibri"/>
+              </a:rPr>
+              <a:t>seguimiento</a:t>
+            </a:r>
+            <a:r>
+              <a:rPr sz="1200" b="0" dirty="0">
+                <a:solidFill>
+                  <a:srgbClr val="CADCFC"/>
+                </a:solidFill>
+                <a:latin typeface="Calibri"/>
+              </a:rPr>
+              <a:t> y la </a:t>
+            </a:r>
+            <a:r>
+              <a:rPr sz="1200" b="0" dirty="0" err="1">
+                <a:solidFill>
+                  <a:srgbClr val="CADCFC"/>
+                </a:solidFill>
+                <a:latin typeface="Calibri"/>
+              </a:rPr>
+              <a:t>evaluación</a:t>
+            </a:r>
+            <a:r>
+              <a:rPr sz="1200" b="0" dirty="0">
+                <a:solidFill>
+                  <a:srgbClr val="CADCFC"/>
+                </a:solidFill>
+                <a:latin typeface="Calibri"/>
+              </a:rPr>
+              <a:t> de </a:t>
+            </a:r>
+            <a:r>
+              <a:rPr sz="1200" b="0" dirty="0" err="1">
+                <a:solidFill>
+                  <a:srgbClr val="CADCFC"/>
+                </a:solidFill>
+                <a:latin typeface="Calibri"/>
+              </a:rPr>
+              <a:t>los</a:t>
+            </a:r>
+            <a:r>
+              <a:rPr sz="1200" b="0" dirty="0">
+                <a:solidFill>
+                  <a:srgbClr val="CADCFC"/>
+                </a:solidFill>
+                <a:latin typeface="Calibri"/>
+              </a:rPr>
+              <a:t> </a:t>
+            </a:r>
+            <a:r>
+              <a:rPr sz="1200" b="0" dirty="0" err="1">
+                <a:solidFill>
+                  <a:srgbClr val="CADCFC"/>
+                </a:solidFill>
+                <a:latin typeface="Calibri"/>
+              </a:rPr>
+              <a:t>proyectos</a:t>
+            </a:r>
+            <a:r>
+              <a:rPr sz="1200" b="0" dirty="0">
+                <a:solidFill>
+                  <a:srgbClr val="CADCFC"/>
+                </a:solidFill>
+                <a:latin typeface="Calibri"/>
+              </a:rPr>
+              <a:t> </a:t>
+            </a:r>
+            <a:r>
+              <a:rPr sz="1200" b="0" dirty="0" err="1">
+                <a:solidFill>
+                  <a:srgbClr val="CADCFC"/>
+                </a:solidFill>
+                <a:latin typeface="Calibri"/>
+              </a:rPr>
+              <a:t>estratégicos</a:t>
+            </a:r>
+            <a:r>
+              <a:rPr sz="1200" b="0" dirty="0">
+                <a:solidFill>
+                  <a:srgbClr val="CADCFC"/>
+                </a:solidFill>
+                <a:latin typeface="Calibri"/>
+              </a:rPr>
+              <a:t> de la Universidad.</a:t>
             </a:r>
           </a:p>
           <a:p>
@@ -4500,7 +4626,7 @@
                 <a:spcPct val="122000"/>
               </a:lnSpc>
             </a:pPr>
-            <a:endParaRPr sz="1200" b="0">
+            <a:endParaRPr sz="1200" b="0" dirty="0">
               <a:solidFill>
                 <a:srgbClr val="CADCFC"/>
               </a:solidFill>
@@ -4514,13 +4640,31 @@
               </a:lnSpc>
             </a:pPr>
             <a:r>
-              <a:rPr sz="1200" b="0">
+              <a:rPr sz="1200" b="0" dirty="0">
                 <a:solidFill>
                   <a:srgbClr val="CADCFC"/>
                 </a:solidFill>
                 <a:latin typeface="Calibri"/>
               </a:rPr>
-              <a:t>Supervisor de la práctica:</a:t>
+              <a:t>Supervisor de la </a:t>
+            </a:r>
+            <a:r>
+              <a:rPr sz="1200" b="0" dirty="0" err="1">
+                <a:solidFill>
+                  <a:srgbClr val="CADCFC"/>
+                </a:solidFill>
+                <a:latin typeface="Calibri"/>
+              </a:rPr>
+              <a:t>práctica</a:t>
+            </a:r>
+            <a:r>
+              <a:rPr sz="1200" b="0" dirty="0">
+                <a:solidFill>
+                  <a:srgbClr val="CADCFC"/>
+                </a:solidFill>
+                <a:latin typeface="Calibri"/>
+              </a:rPr>
+              <a:t>:</a:t>
             </a:r>
           </a:p>
           <a:p>
@@ -4530,7 +4674,7 @@
               </a:lnSpc>
             </a:pPr>
             <a:r>
-              <a:rPr sz="1200" b="0">
+              <a:rPr sz="1200" b="0" dirty="0">
                 <a:solidFill>
                   <a:srgbClr val="CADCFC"/>
                 </a:solidFill>
@@ -4546,13 +4690,58 @@
               </a:lnSpc>
             </a:pPr>
             <a:r>
-              <a:rPr sz="1200" b="0">
+              <a:rPr sz="1200" b="0" dirty="0" err="1">
                 <a:solidFill>
                   <a:srgbClr val="CADCFC"/>
                 </a:solidFill>
                 <a:latin typeface="Calibri"/>
               </a:rPr>
-              <a:t>Coordinador del Programa en TICS.</a:t>
+              <a:t>Coordinador</a:t>
+            </a:r>
+            <a:r>
+              <a:rPr sz="1200" b="0" dirty="0">
+                <a:solidFill>
+                  <a:srgbClr val="CADCFC"/>
+                </a:solidFill>
+                <a:latin typeface="Calibri"/>
+              </a:rPr>
+              <a:t> del </a:t>
+            </a:r>
+            <a:r>
+              <a:rPr sz="1200" b="0" dirty="0" err="1">
+                <a:solidFill>
+                  <a:srgbClr val="CADCFC"/>
+                </a:solidFill>
+                <a:latin typeface="Calibri"/>
+              </a:rPr>
+              <a:t>Programa</a:t>
+            </a:r>
+            <a:r>
+              <a:rPr sz="1200" b="0" dirty="0">
+                <a:solidFill>
+                  <a:srgbClr val="CADCFC"/>
+                </a:solidFill>
+                <a:latin typeface="Calibri"/>
+              </a:rPr>
+              <a:t> </a:t>
+            </a:r>
+            <a:r>
+              <a:rPr sz="1200" b="0" dirty="0" err="1">
+                <a:solidFill>
+                  <a:srgbClr val="CADCFC"/>
+                </a:solidFill>
+                <a:latin typeface="Calibri"/>
+              </a:rPr>
+              <a:t>en</a:t>
+            </a:r>
+            <a:r>
+              <a:rPr sz="1200" b="0" dirty="0">
+                <a:solidFill>
+                  <a:srgbClr val="CADCFC"/>
+                </a:solidFill>
+                <a:latin typeface="Calibri"/>
+              </a:rPr>
+              <a:t> TICS.</a:t>
             </a:r>
           </a:p>
         </p:txBody>
@@ -11864,13 +12053,445 @@
               </a:lnSpc>
             </a:pPr>
             <a:r>
-              <a:rPr sz="1200" b="0">
+              <a:rPr sz="1200" b="0" dirty="0">
                 <a:solidFill>
                   <a:srgbClr val="475569"/>
                 </a:solidFill>
                 <a:latin typeface="Calibri"/>
               </a:rPr>
-              <a:t>La matriz de acciones se llenaba a mano en un archivo de Excel. La información se pedía por correo a cada sede, se copiaba y se pegaba, y cada persona podía escribir el nombre de un objetivo, una meta o un beneficiario de forma distinta. Es un proceso lento y difícil de verificar.</a:t>
+              <a:t>La </a:t>
+            </a:r>
+            <a:r>
+              <a:rPr sz="1200" b="0" dirty="0" err="1">
+                <a:solidFill>
+                  <a:srgbClr val="475569"/>
+                </a:solidFill>
+                <a:latin typeface="Calibri"/>
+              </a:rPr>
+              <a:t>matriz</a:t>
+            </a:r>
+            <a:r>
+              <a:rPr sz="1200" b="0" dirty="0">
+                <a:solidFill>
+                  <a:srgbClr val="475569"/>
+                </a:solidFill>
+                <a:latin typeface="Calibri"/>
+              </a:rPr>
+              <a:t> de </a:t>
+            </a:r>
+            <a:r>
+              <a:rPr sz="1200" b="0" dirty="0" err="1">
+                <a:solidFill>
+                  <a:srgbClr val="475569"/>
+                </a:solidFill>
+                <a:latin typeface="Calibri"/>
+              </a:rPr>
+              <a:t>acciones</a:t>
+            </a:r>
+            <a:r>
+              <a:rPr sz="1200" b="0" dirty="0">
+                <a:solidFill>
+                  <a:srgbClr val="475569"/>
+                </a:solidFill>
+                <a:latin typeface="Calibri"/>
+              </a:rPr>
+              <a:t> se </a:t>
+            </a:r>
+            <a:r>
+              <a:rPr sz="1200" b="0" dirty="0" err="1">
+                <a:solidFill>
+                  <a:srgbClr val="475569"/>
+                </a:solidFill>
+                <a:latin typeface="Calibri"/>
+              </a:rPr>
+              <a:t>llenaba</a:t>
+            </a:r>
+            <a:r>
+              <a:rPr sz="1200" b="0" dirty="0">
+                <a:solidFill>
+                  <a:srgbClr val="475569"/>
+                </a:solidFill>
+                <a:latin typeface="Calibri"/>
+              </a:rPr>
+              <a:t> a mano </a:t>
+            </a:r>
+            <a:r>
+              <a:rPr sz="1200" b="0" dirty="0" err="1">
+                <a:solidFill>
+                  <a:srgbClr val="475569"/>
+                </a:solidFill>
+                <a:latin typeface="Calibri"/>
+              </a:rPr>
+              <a:t>en</a:t>
+            </a:r>
+            <a:r>
+              <a:rPr sz="1200" b="0" dirty="0">
+                <a:solidFill>
+                  <a:srgbClr val="475569"/>
+                </a:solidFill>
+                <a:latin typeface="Calibri"/>
+              </a:rPr>
+              <a:t> un </a:t>
+            </a:r>
+            <a:r>
+              <a:rPr sz="1200" b="0" dirty="0" err="1">
+                <a:solidFill>
+                  <a:srgbClr val="475569"/>
+                </a:solidFill>
+                <a:latin typeface="Calibri"/>
+              </a:rPr>
+              <a:t>archivo</a:t>
+            </a:r>
+            <a:r>
+              <a:rPr sz="1200" b="0" dirty="0">
+                <a:solidFill>
+                  <a:srgbClr val="475569"/>
+                </a:solidFill>
+                <a:latin typeface="Calibri"/>
+              </a:rPr>
+              <a:t> de Excel. La </a:t>
+            </a:r>
+            <a:r>
+              <a:rPr sz="1200" b="0" dirty="0" err="1">
+                <a:solidFill>
+                  <a:srgbClr val="475569"/>
+                </a:solidFill>
+                <a:latin typeface="Calibri"/>
+              </a:rPr>
+              <a:t>información</a:t>
+            </a:r>
+            <a:r>
+              <a:rPr sz="1200" b="0" dirty="0">
+                <a:solidFill>
+                  <a:srgbClr val="475569"/>
+                </a:solidFill>
+                <a:latin typeface="Calibri"/>
+              </a:rPr>
+              <a:t> se </a:t>
+            </a:r>
+            <a:r>
+              <a:rPr sz="1200" b="0" dirty="0" err="1">
+                <a:solidFill>
+                  <a:srgbClr val="475569"/>
+                </a:solidFill>
+                <a:latin typeface="Calibri"/>
+              </a:rPr>
+              <a:t>pedía</a:t>
+            </a:r>
+            <a:r>
+              <a:rPr sz="1200" b="0" dirty="0">
+                <a:solidFill>
+                  <a:srgbClr val="475569"/>
+                </a:solidFill>
+                <a:latin typeface="Calibri"/>
+              </a:rPr>
+              <a:t> </a:t>
+            </a:r>
+            <a:r>
+              <a:rPr sz="1200" b="0" dirty="0" err="1">
+                <a:solidFill>
+                  <a:srgbClr val="475569"/>
+                </a:solidFill>
+                <a:latin typeface="Calibri"/>
+              </a:rPr>
+              <a:t>por</a:t>
+            </a:r>
+            <a:r>
+              <a:rPr sz="1200" b="0" dirty="0">
+                <a:solidFill>
+                  <a:srgbClr val="475569"/>
+                </a:solidFill>
+                <a:latin typeface="Calibri"/>
+              </a:rPr>
+              <a:t> </a:t>
+            </a:r>
+            <a:r>
+              <a:rPr sz="1200" b="0" dirty="0" err="1">
+                <a:solidFill>
+                  <a:srgbClr val="475569"/>
+                </a:solidFill>
+                <a:latin typeface="Calibri"/>
+              </a:rPr>
+              <a:t>correo</a:t>
+            </a:r>
+            <a:r>
+              <a:rPr sz="1200" b="0" dirty="0">
+                <a:solidFill>
+                  <a:srgbClr val="475569"/>
+                </a:solidFill>
+                <a:latin typeface="Calibri"/>
+              </a:rPr>
+              <a:t> a </a:t>
+            </a:r>
+            <a:r>
+              <a:rPr sz="1200" b="0" dirty="0" err="1">
+                <a:solidFill>
+                  <a:srgbClr val="475569"/>
+                </a:solidFill>
+                <a:latin typeface="Calibri"/>
+              </a:rPr>
+              <a:t>cada</a:t>
+            </a:r>
+            <a:r>
+              <a:rPr sz="1200" b="0" dirty="0">
+                <a:solidFill>
+                  <a:srgbClr val="475569"/>
+                </a:solidFill>
+                <a:latin typeface="Calibri"/>
+              </a:rPr>
+              <a:t> </a:t>
+            </a:r>
+            <a:r>
+              <a:rPr sz="1200" b="0" dirty="0" err="1">
+                <a:solidFill>
+                  <a:srgbClr val="475569"/>
+                </a:solidFill>
+                <a:latin typeface="Calibri"/>
+              </a:rPr>
+              <a:t>sede</a:t>
+            </a:r>
+            <a:r>
+              <a:rPr sz="1200" b="0" dirty="0">
+                <a:solidFill>
+                  <a:srgbClr val="475569"/>
+                </a:solidFill>
+                <a:latin typeface="Calibri"/>
+              </a:rPr>
+              <a:t>, se </a:t>
+            </a:r>
+            <a:r>
+              <a:rPr sz="1200" b="0" dirty="0" err="1">
+                <a:solidFill>
+                  <a:srgbClr val="475569"/>
+                </a:solidFill>
+                <a:latin typeface="Calibri"/>
+              </a:rPr>
+              <a:t>copiaba</a:t>
+            </a:r>
+            <a:r>
+              <a:rPr sz="1200" b="0" dirty="0">
+                <a:solidFill>
+                  <a:srgbClr val="475569"/>
+                </a:solidFill>
+                <a:latin typeface="Calibri"/>
+              </a:rPr>
+              <a:t> y se </a:t>
+            </a:r>
+            <a:r>
+              <a:rPr sz="1200" b="0" dirty="0" err="1">
+                <a:solidFill>
+                  <a:srgbClr val="475569"/>
+                </a:solidFill>
+                <a:latin typeface="Calibri"/>
+              </a:rPr>
+              <a:t>pegaba</a:t>
+            </a:r>
+            <a:r>
+              <a:rPr sz="1200" b="0" dirty="0">
+                <a:solidFill>
+                  <a:srgbClr val="475569"/>
+                </a:solidFill>
+                <a:latin typeface="Calibri"/>
+              </a:rPr>
+              <a:t>, y </a:t>
+            </a:r>
+            <a:r>
+              <a:rPr sz="1200" b="0" dirty="0" err="1">
+                <a:solidFill>
+                  <a:srgbClr val="475569"/>
+                </a:solidFill>
+                <a:latin typeface="Calibri"/>
+              </a:rPr>
+              <a:t>cada</a:t>
+            </a:r>
+            <a:r>
+              <a:rPr sz="1200" b="0" dirty="0">
+                <a:solidFill>
+                  <a:srgbClr val="475569"/>
+                </a:solidFill>
+                <a:latin typeface="Calibri"/>
+              </a:rPr>
+              <a:t> persona </a:t>
+            </a:r>
+            <a:r>
+              <a:rPr sz="1200" b="0" dirty="0" err="1">
+                <a:solidFill>
+                  <a:srgbClr val="475569"/>
+                </a:solidFill>
+                <a:latin typeface="Calibri"/>
+              </a:rPr>
+              <a:t>podía</a:t>
+            </a:r>
+            <a:r>
+              <a:rPr sz="1200" b="0" dirty="0">
+                <a:solidFill>
+                  <a:srgbClr val="475569"/>
+                </a:solidFill>
+                <a:latin typeface="Calibri"/>
+              </a:rPr>
+              <a:t> </a:t>
+            </a:r>
+            <a:r>
+              <a:rPr sz="1200" b="0" dirty="0" err="1">
+                <a:solidFill>
+                  <a:srgbClr val="475569"/>
+                </a:solidFill>
+                <a:latin typeface="Calibri"/>
+              </a:rPr>
+              <a:t>escribir</a:t>
+            </a:r>
+            <a:r>
+              <a:rPr sz="1200" b="0" dirty="0">
+                <a:solidFill>
+                  <a:srgbClr val="475569"/>
+                </a:solidFill>
+                <a:latin typeface="Calibri"/>
+              </a:rPr>
+              <a:t> el </a:t>
+            </a:r>
+            <a:r>
+              <a:rPr sz="1200" b="0" dirty="0" err="1">
+                <a:solidFill>
+                  <a:srgbClr val="475569"/>
+                </a:solidFill>
+                <a:latin typeface="Calibri"/>
+              </a:rPr>
+              <a:t>nombre</a:t>
+            </a:r>
+            <a:r>
+              <a:rPr sz="1200" b="0" dirty="0">
+                <a:solidFill>
+                  <a:srgbClr val="475569"/>
+                </a:solidFill>
+                <a:latin typeface="Calibri"/>
+              </a:rPr>
+              <a:t> de un </a:t>
+            </a:r>
+            <a:r>
+              <a:rPr sz="1200" b="0" dirty="0" err="1">
+                <a:solidFill>
+                  <a:srgbClr val="475569"/>
+                </a:solidFill>
+                <a:latin typeface="Calibri"/>
+              </a:rPr>
+              <a:t>objetivo</a:t>
+            </a:r>
+            <a:r>
+              <a:rPr sz="1200" b="0" dirty="0">
+                <a:solidFill>
+                  <a:srgbClr val="475569"/>
+                </a:solidFill>
+                <a:latin typeface="Calibri"/>
+              </a:rPr>
+              <a:t>, </a:t>
+            </a:r>
+            <a:r>
+              <a:rPr sz="1200" b="0" dirty="0" err="1">
+                <a:solidFill>
+                  <a:srgbClr val="475569"/>
+                </a:solidFill>
+                <a:latin typeface="Calibri"/>
+              </a:rPr>
+              <a:t>una</a:t>
+            </a:r>
+            <a:r>
+              <a:rPr sz="1200" b="0" dirty="0">
+                <a:solidFill>
+                  <a:srgbClr val="475569"/>
+                </a:solidFill>
+                <a:latin typeface="Calibri"/>
+              </a:rPr>
+              <a:t> meta o un </a:t>
+            </a:r>
+            <a:r>
+              <a:rPr sz="1200" b="0" dirty="0" err="1">
+                <a:solidFill>
+                  <a:srgbClr val="475569"/>
+                </a:solidFill>
+                <a:latin typeface="Calibri"/>
+              </a:rPr>
+              <a:t>beneficiario</a:t>
+            </a:r>
+            <a:r>
+              <a:rPr sz="1200" b="0" dirty="0">
+                <a:solidFill>
+                  <a:srgbClr val="475569"/>
+                </a:solidFill>
+                <a:latin typeface="Calibri"/>
+              </a:rPr>
+              <a:t> de forma </a:t>
+            </a:r>
+            <a:r>
+              <a:rPr sz="1200" b="0" dirty="0" err="1">
+                <a:solidFill>
+                  <a:srgbClr val="475569"/>
+                </a:solidFill>
+                <a:latin typeface="Calibri"/>
+              </a:rPr>
+              <a:t>distinta</a:t>
+            </a:r>
+            <a:r>
+              <a:rPr sz="1200" b="0" dirty="0">
+                <a:solidFill>
+                  <a:srgbClr val="475569"/>
+                </a:solidFill>
+                <a:latin typeface="Calibri"/>
+              </a:rPr>
+              <a:t>. Es un </a:t>
+            </a:r>
+            <a:r>
+              <a:rPr sz="1200" b="0" dirty="0" err="1">
+                <a:solidFill>
+                  <a:srgbClr val="475569"/>
+                </a:solidFill>
+                <a:latin typeface="Calibri"/>
+              </a:rPr>
+              <a:t>proceso</a:t>
+            </a:r>
+            <a:r>
+              <a:rPr sz="1200" b="0" dirty="0">
+                <a:solidFill>
+                  <a:srgbClr val="475569"/>
+                </a:solidFill>
+                <a:latin typeface="Calibri"/>
+              </a:rPr>
+              <a:t> lento y </a:t>
+            </a:r>
+            <a:r>
+              <a:rPr sz="1200" b="0" dirty="0" err="1">
+                <a:solidFill>
+                  <a:srgbClr val="475569"/>
+                </a:solidFill>
+                <a:latin typeface="Calibri"/>
+              </a:rPr>
+              <a:t>difícil</a:t>
+            </a:r>
+            <a:r>
+              <a:rPr sz="1200" b="0" dirty="0">
+                <a:solidFill>
+                  <a:srgbClr val="475569"/>
+                </a:solidFill>
+                <a:latin typeface="Calibri"/>
+              </a:rPr>
+              <a:t> de </a:t>
+            </a:r>
+            <a:r>
+              <a:rPr sz="1200" b="0" dirty="0" err="1">
+                <a:solidFill>
+                  <a:srgbClr val="475569"/>
+                </a:solidFill>
+                <a:latin typeface="Calibri"/>
+              </a:rPr>
+              <a:t>verificar</a:t>
+            </a:r>
+            <a:r>
+              <a:rPr sz="1200" b="0" dirty="0">
+                <a:solidFill>
+                  <a:srgbClr val="475569"/>
+                </a:solidFill>
+                <a:latin typeface="Calibri"/>
+              </a:rPr>
+              <a:t>.</a:t>
             </a:r>
           </a:p>
         </p:txBody>
@@ -22116,7 +22737,7 @@
           <a:lstStyle/>
           <a:p>
             <a:pPr algn="ctr"/>
-            <a:endParaRPr/>
+            <a:endParaRPr dirty="0"/>
           </a:p>
         </p:txBody>
       </p:sp>
@@ -22211,7 +22832,7 @@
         <p:spPr>
           <a:xfrm>
             <a:off x="3511296" y="4462272"/>
-            <a:ext cx="2331720" cy="1325880"/>
+            <a:ext cx="2331720" cy="613245"/>
           </a:xfrm>
           <a:prstGeom prst="rect">
             <a:avLst/>
@@ -22230,13 +22851,175 @@
               </a:lnSpc>
             </a:pPr>
             <a:r>
-              <a:rPr sz="1150" b="0">
+              <a:rPr sz="1150" b="0" dirty="0">
                 <a:solidFill>
                   <a:srgbClr val="64748B"/>
                 </a:solidFill>
                 <a:latin typeface="Calibri"/>
               </a:rPr>
-              <a:t>Los 239 indicadores oficiales de Naciones Unidas como catálogo único de referencia.</a:t>
+              <a:t>L</a:t>
+            </a:r>
+            <a:r>
+              <a:rPr lang="en-US" sz="1150" b="0" dirty="0">
+                <a:solidFill>
+                  <a:srgbClr val="64748B"/>
+                </a:solidFill>
+                <a:latin typeface="Calibri"/>
+              </a:rPr>
+              <a:t>as </a:t>
+            </a:r>
+            <a:r>
+              <a:rPr lang="en-US" sz="1150" b="0" dirty="0" err="1">
+                <a:solidFill>
+                  <a:srgbClr val="64748B"/>
+                </a:solidFill>
+                <a:latin typeface="Calibri"/>
+              </a:rPr>
+              <a:t>metas</a:t>
+            </a:r>
+            <a:r>
+              <a:rPr lang="en-US" sz="1150" b="0" dirty="0">
+                <a:solidFill>
+                  <a:srgbClr val="64748B"/>
+                </a:solidFill>
+                <a:latin typeface="Calibri"/>
+              </a:rPr>
+              <a:t> y sus</a:t>
+            </a:r>
+            <a:r>
+              <a:rPr sz="1150" b="0" dirty="0">
+                <a:solidFill>
+                  <a:srgbClr val="64748B"/>
+                </a:solidFill>
+                <a:latin typeface="Calibri"/>
+              </a:rPr>
+              <a:t> 239 </a:t>
+            </a:r>
+            <a:r>
+              <a:rPr sz="1150" b="0" dirty="0" err="1">
+                <a:solidFill>
+                  <a:srgbClr val="64748B"/>
+                </a:solidFill>
+                <a:latin typeface="Calibri"/>
+              </a:rPr>
+              <a:t>indicadores</a:t>
+            </a:r>
+            <a:r>
+              <a:rPr sz="1150" b="0" dirty="0">
+                <a:solidFill>
+                  <a:srgbClr val="64748B"/>
+                </a:solidFill>
+                <a:latin typeface="Calibri"/>
+              </a:rPr>
+              <a:t> </a:t>
+            </a:r>
+            <a:r>
+              <a:rPr sz="1150" b="0" dirty="0" err="1">
+                <a:solidFill>
+                  <a:srgbClr val="64748B"/>
+                </a:solidFill>
+                <a:latin typeface="Calibri"/>
+              </a:rPr>
+              <a:t>oficiales</a:t>
+            </a:r>
+            <a:r>
+              <a:rPr sz="1150" b="0" dirty="0">
+                <a:solidFill>
+                  <a:srgbClr val="64748B"/>
+                </a:solidFill>
+                <a:latin typeface="Calibri"/>
+              </a:rPr>
+              <a:t> de </a:t>
+            </a:r>
+            <a:r>
+              <a:rPr sz="1150" b="0" dirty="0" err="1">
+                <a:solidFill>
+                  <a:srgbClr val="64748B"/>
+                </a:solidFill>
+                <a:latin typeface="Calibri"/>
+              </a:rPr>
+              <a:t>Naciones</a:t>
+            </a:r>
+            <a:r>
+              <a:rPr sz="1150" b="0" dirty="0">
+                <a:solidFill>
+                  <a:srgbClr val="64748B"/>
+                </a:solidFill>
+                <a:latin typeface="Calibri"/>
+              </a:rPr>
+              <a:t> Unidas </a:t>
+            </a:r>
+            <a:r>
+              <a:rPr sz="1150" b="0" dirty="0" err="1">
+                <a:solidFill>
+                  <a:srgbClr val="64748B"/>
+                </a:solidFill>
+                <a:latin typeface="Calibri"/>
+              </a:rPr>
+              <a:t>como</a:t>
+            </a:r>
+            <a:r>
+              <a:rPr sz="1150" b="0" dirty="0">
+                <a:solidFill>
+                  <a:srgbClr val="64748B"/>
+                </a:solidFill>
+                <a:latin typeface="Calibri"/>
+              </a:rPr>
+              <a:t> </a:t>
+            </a:r>
+            <a:r>
+              <a:rPr sz="1150" b="0" dirty="0" err="1">
+                <a:solidFill>
+                  <a:srgbClr val="64748B"/>
+                </a:solidFill>
+                <a:latin typeface="Calibri"/>
+              </a:rPr>
+              <a:t>catálogo</a:t>
+            </a:r>
+            <a:r>
+              <a:rPr sz="1150" b="0" dirty="0">
+                <a:solidFill>
+                  <a:srgbClr val="64748B"/>
+                </a:solidFill>
+                <a:latin typeface="Calibri"/>
+              </a:rPr>
+              <a:t> </a:t>
+            </a:r>
+            <a:r>
+              <a:rPr sz="1150" b="0" dirty="0" err="1">
+                <a:solidFill>
+                  <a:srgbClr val="64748B"/>
+                </a:solidFill>
+                <a:latin typeface="Calibri"/>
+              </a:rPr>
+              <a:t>único</a:t>
+            </a:r>
+            <a:r>
+              <a:rPr sz="1150" b="0" dirty="0">
+                <a:solidFill>
+                  <a:srgbClr val="64748B"/>
+                </a:solidFill>
+                <a:latin typeface="Calibri"/>
+              </a:rPr>
+              <a:t> de </a:t>
+            </a:r>
+            <a:r>
+              <a:rPr sz="1150" b="0" dirty="0" err="1">
+                <a:solidFill>
+                  <a:srgbClr val="64748B"/>
+                </a:solidFill>
+                <a:latin typeface="Calibri"/>
+              </a:rPr>
+              <a:t>referencia</a:t>
+            </a:r>
+            <a:r>
+              <a:rPr sz="1150" b="0" dirty="0">
+                <a:solidFill>
+                  <a:srgbClr val="64748B"/>
+                </a:solidFill>
+                <a:latin typeface="Calibri"/>
+              </a:rPr>
+              <a:t>.</a:t>
             </a:r>
           </a:p>
         </p:txBody>

</xml_diff>